<commit_message>
feat: restore project updates on dev
</commit_message>
<xml_diff>
--- a/public/ppt_template/模板.pptx
+++ b/public/ppt_template/模板.pptx
@@ -3289,10 +3289,14 @@
           </a:lstStyle>
           <a:p>
             <a:r>
-              <a:rPr lang="en-US" dirty="0"/>
-              <a:t>{technical_name}</a:t>
-            </a:r>
-            <a:endParaRPr lang="en-US" dirty="0"/>
+              <a:rPr lang="zh-CN" altLang="en-US" dirty="0"/>
+              <a:t>技术</a:t>
+            </a:r>
+            <a:r>
+              <a:rPr lang="zh-CN" altLang="en-US" dirty="0"/>
+              <a:t>背景</a:t>
+            </a:r>
+            <a:endParaRPr lang="zh-CN" altLang="en-US" dirty="0"/>
           </a:p>
         </p:txBody>
       </p:sp>
@@ -3346,82 +3350,6 @@
       </p:sp>
       <p:sp>
         <p:nvSpPr>
-          <p:cNvPr id="78" name="矩形: 圆角 3"/>
-          <p:cNvSpPr/>
-          <p:nvPr/>
-        </p:nvSpPr>
-        <p:spPr>
-          <a:xfrm>
-            <a:off x="314960" y="1508760"/>
-            <a:ext cx="3707130" cy="431800"/>
-          </a:xfrm>
-          <a:prstGeom prst="roundRect">
-            <a:avLst>
-              <a:gd name="adj" fmla="val 0"/>
-            </a:avLst>
-          </a:prstGeom>
-          <a:solidFill>
-            <a:srgbClr val="004698"/>
-          </a:solidFill>
-          <a:ln>
-            <a:solidFill>
-              <a:srgbClr val="004698"/>
-            </a:solidFill>
-          </a:ln>
-        </p:spPr>
-        <p:style>
-          <a:lnRef idx="2">
-            <a:schemeClr val="accent1">
-              <a:shade val="15000"/>
-            </a:schemeClr>
-          </a:lnRef>
-          <a:fillRef idx="1">
-            <a:schemeClr val="accent1"/>
-          </a:fillRef>
-          <a:effectRef idx="0">
-            <a:schemeClr val="accent1"/>
-          </a:effectRef>
-          <a:fontRef idx="minor">
-            <a:schemeClr val="lt1"/>
-          </a:fontRef>
-        </p:style>
-        <p:txBody>
-          <a:bodyPr rtlCol="0" anchor="t" anchorCtr="0"/>
-          <a:lstStyle/>
-          <a:p>
-            <a:pPr algn="ctr"/>
-            <a:r>
-              <a:rPr lang="en-US" altLang="zh-CN" sz="2000" b="1" dirty="0">
-                <a:solidFill>
-                  <a:schemeClr val="bg1"/>
-                </a:solidFill>
-                <a:latin typeface="微软雅黑" panose="020B0503020204020204" charset="-122"/>
-                <a:ea typeface="微软雅黑" panose="020B0503020204020204" charset="-122"/>
-              </a:rPr>
-              <a:t>{technical_principle_title}</a:t>
-            </a:r>
-            <a:endParaRPr lang="en-US" altLang="zh-CN" sz="2000" b="1" dirty="0">
-              <a:solidFill>
-                <a:schemeClr val="bg1"/>
-              </a:solidFill>
-              <a:latin typeface="微软雅黑" panose="020B0503020204020204" charset="-122"/>
-              <a:ea typeface="微软雅黑" panose="020B0503020204020204" charset="-122"/>
-            </a:endParaRPr>
-          </a:p>
-          <a:p>
-            <a:pPr algn="ctr"/>
-            <a:endParaRPr lang="en-US" altLang="zh-CN" sz="2000" b="1" dirty="0">
-              <a:solidFill>
-                <a:schemeClr val="bg1"/>
-              </a:solidFill>
-              <a:latin typeface="微软雅黑" panose="020B0503020204020204" charset="-122"/>
-              <a:ea typeface="微软雅黑" panose="020B0503020204020204" charset="-122"/>
-            </a:endParaRPr>
-          </a:p>
-        </p:txBody>
-      </p:sp>
-      <p:sp>
-        <p:nvSpPr>
           <p:cNvPr id="2" name="文本框 1"/>
           <p:cNvSpPr txBox="1"/>
           <p:nvPr/>
@@ -3472,7 +3400,24 @@
                 <a:ea typeface="微软雅黑" panose="020B0503020204020204" charset="-122"/>
                 <a:sym typeface="+mn-ea"/>
               </a:rPr>
-              <a:t>{technical_type}</a:t>
+              <a:t>{technical_</a:t>
+            </a:r>
+            <a:r>
+              <a:rPr lang="en-US" altLang="zh-CN" sz="3600" b="1" noProof="0" dirty="0">
+                <a:ln>
+                  <a:noFill/>
+                </a:ln>
+                <a:solidFill>
+                  <a:srgbClr val="C00000"/>
+                </a:solidFill>
+                <a:effectLst/>
+                <a:uLnTx/>
+                <a:uFillTx/>
+                <a:latin typeface="微软雅黑" panose="020B0503020204020204" charset="-122"/>
+                <a:ea typeface="微软雅黑" panose="020B0503020204020204" charset="-122"/>
+                <a:sym typeface="+mn-ea"/>
+              </a:rPr>
+              <a:t>name}</a:t>
             </a:r>
             <a:endParaRPr lang="en-US" sz="3600" b="1" noProof="0" dirty="0">
               <a:ln>
@@ -3894,10 +3839,14 @@
           </a:lstStyle>
           <a:p>
             <a:r>
-              <a:rPr lang="en-US" dirty="0"/>
-              <a:t>{technical_name}</a:t>
-            </a:r>
-            <a:endParaRPr lang="en-US" dirty="0"/>
+              <a:rPr lang="zh-CN" altLang="en-US" dirty="0"/>
+              <a:t>技术</a:t>
+            </a:r>
+            <a:r>
+              <a:rPr lang="zh-CN" altLang="en-US" dirty="0"/>
+              <a:t>原理</a:t>
+            </a:r>
+            <a:endParaRPr lang="zh-CN" altLang="en-US" dirty="0"/>
           </a:p>
         </p:txBody>
       </p:sp>
@@ -3951,82 +3900,6 @@
       </p:sp>
       <p:sp>
         <p:nvSpPr>
-          <p:cNvPr id="78" name="矩形: 圆角 3"/>
-          <p:cNvSpPr/>
-          <p:nvPr/>
-        </p:nvSpPr>
-        <p:spPr>
-          <a:xfrm>
-            <a:off x="314960" y="1508760"/>
-            <a:ext cx="3707130" cy="431800"/>
-          </a:xfrm>
-          <a:prstGeom prst="roundRect">
-            <a:avLst>
-              <a:gd name="adj" fmla="val 0"/>
-            </a:avLst>
-          </a:prstGeom>
-          <a:solidFill>
-            <a:srgbClr val="004698"/>
-          </a:solidFill>
-          <a:ln>
-            <a:solidFill>
-              <a:srgbClr val="004698"/>
-            </a:solidFill>
-          </a:ln>
-        </p:spPr>
-        <p:style>
-          <a:lnRef idx="2">
-            <a:schemeClr val="accent1">
-              <a:shade val="15000"/>
-            </a:schemeClr>
-          </a:lnRef>
-          <a:fillRef idx="1">
-            <a:schemeClr val="accent1"/>
-          </a:fillRef>
-          <a:effectRef idx="0">
-            <a:schemeClr val="accent1"/>
-          </a:effectRef>
-          <a:fontRef idx="minor">
-            <a:schemeClr val="lt1"/>
-          </a:fontRef>
-        </p:style>
-        <p:txBody>
-          <a:bodyPr rtlCol="0" anchor="t" anchorCtr="0"/>
-          <a:lstStyle/>
-          <a:p>
-            <a:pPr algn="ctr"/>
-            <a:r>
-              <a:rPr lang="en-US" altLang="zh-CN" sz="2000" b="1" dirty="0">
-                <a:solidFill>
-                  <a:schemeClr val="bg1"/>
-                </a:solidFill>
-                <a:latin typeface="微软雅黑" panose="020B0503020204020204" charset="-122"/>
-                <a:ea typeface="微软雅黑" panose="020B0503020204020204" charset="-122"/>
-              </a:rPr>
-              <a:t>{technical_feature_title}</a:t>
-            </a:r>
-            <a:endParaRPr lang="en-US" altLang="zh-CN" sz="2000" b="1" dirty="0">
-              <a:solidFill>
-                <a:schemeClr val="bg1"/>
-              </a:solidFill>
-              <a:latin typeface="微软雅黑" panose="020B0503020204020204" charset="-122"/>
-              <a:ea typeface="微软雅黑" panose="020B0503020204020204" charset="-122"/>
-            </a:endParaRPr>
-          </a:p>
-          <a:p>
-            <a:pPr algn="ctr"/>
-            <a:endParaRPr lang="en-US" altLang="zh-CN" sz="2000" b="1" dirty="0">
-              <a:solidFill>
-                <a:schemeClr val="bg1"/>
-              </a:solidFill>
-              <a:latin typeface="微软雅黑" panose="020B0503020204020204" charset="-122"/>
-              <a:ea typeface="微软雅黑" panose="020B0503020204020204" charset="-122"/>
-            </a:endParaRPr>
-          </a:p>
-        </p:txBody>
-      </p:sp>
-      <p:sp>
-        <p:nvSpPr>
           <p:cNvPr id="4" name="文本框 3"/>
           <p:cNvSpPr txBox="1"/>
           <p:nvPr/>
@@ -4077,7 +3950,7 @@
                 <a:ea typeface="微软雅黑" panose="020B0503020204020204" charset="-122"/>
                 <a:sym typeface="+mn-ea"/>
               </a:rPr>
-              <a:t>{technical_type}</a:t>
+              <a:t>{technical_name}</a:t>
             </a:r>
             <a:endParaRPr lang="en-US" sz="3600" b="1" noProof="0" dirty="0">
               <a:ln>
@@ -4471,10 +4344,14 @@
           </a:lstStyle>
           <a:p>
             <a:r>
-              <a:rPr lang="en-US" dirty="0"/>
-              <a:t>{technical_name}</a:t>
-            </a:r>
-            <a:endParaRPr lang="en-US" dirty="0"/>
+              <a:rPr lang="zh-CN" altLang="en-US" dirty="0"/>
+              <a:t>前期应用</a:t>
+            </a:r>
+            <a:r>
+              <a:rPr lang="zh-CN" altLang="en-US" dirty="0"/>
+              <a:t>成果</a:t>
+            </a:r>
+            <a:endParaRPr lang="zh-CN" altLang="en-US" dirty="0"/>
           </a:p>
         </p:txBody>
       </p:sp>
@@ -4528,82 +4405,6 @@
       </p:sp>
       <p:sp>
         <p:nvSpPr>
-          <p:cNvPr id="78" name="矩形: 圆角 3"/>
-          <p:cNvSpPr/>
-          <p:nvPr/>
-        </p:nvSpPr>
-        <p:spPr>
-          <a:xfrm>
-            <a:off x="314960" y="1508760"/>
-            <a:ext cx="3707130" cy="431800"/>
-          </a:xfrm>
-          <a:prstGeom prst="roundRect">
-            <a:avLst>
-              <a:gd name="adj" fmla="val 0"/>
-            </a:avLst>
-          </a:prstGeom>
-          <a:solidFill>
-            <a:srgbClr val="004698"/>
-          </a:solidFill>
-          <a:ln>
-            <a:solidFill>
-              <a:srgbClr val="004698"/>
-            </a:solidFill>
-          </a:ln>
-        </p:spPr>
-        <p:style>
-          <a:lnRef idx="2">
-            <a:schemeClr val="accent1">
-              <a:shade val="15000"/>
-            </a:schemeClr>
-          </a:lnRef>
-          <a:fillRef idx="1">
-            <a:schemeClr val="accent1"/>
-          </a:fillRef>
-          <a:effectRef idx="0">
-            <a:schemeClr val="accent1"/>
-          </a:effectRef>
-          <a:fontRef idx="minor">
-            <a:schemeClr val="lt1"/>
-          </a:fontRef>
-        </p:style>
-        <p:txBody>
-          <a:bodyPr rtlCol="0" anchor="t" anchorCtr="0"/>
-          <a:lstStyle/>
-          <a:p>
-            <a:pPr algn="ctr"/>
-            <a:r>
-              <a:rPr lang="en-US" altLang="zh-CN" sz="2000" b="1" dirty="0">
-                <a:solidFill>
-                  <a:schemeClr val="bg1"/>
-                </a:solidFill>
-                <a:latin typeface="微软雅黑" panose="020B0503020204020204" charset="-122"/>
-                <a:ea typeface="微软雅黑" panose="020B0503020204020204" charset="-122"/>
-              </a:rPr>
-              <a:t>{technical_application_title}</a:t>
-            </a:r>
-            <a:endParaRPr lang="en-US" altLang="zh-CN" sz="2000" b="1" dirty="0">
-              <a:solidFill>
-                <a:schemeClr val="bg1"/>
-              </a:solidFill>
-              <a:latin typeface="微软雅黑" panose="020B0503020204020204" charset="-122"/>
-              <a:ea typeface="微软雅黑" panose="020B0503020204020204" charset="-122"/>
-            </a:endParaRPr>
-          </a:p>
-          <a:p>
-            <a:pPr algn="ctr"/>
-            <a:endParaRPr lang="en-US" altLang="zh-CN" sz="2000" b="1" dirty="0">
-              <a:solidFill>
-                <a:schemeClr val="bg1"/>
-              </a:solidFill>
-              <a:latin typeface="微软雅黑" panose="020B0503020204020204" charset="-122"/>
-              <a:ea typeface="微软雅黑" panose="020B0503020204020204" charset="-122"/>
-            </a:endParaRPr>
-          </a:p>
-        </p:txBody>
-      </p:sp>
-      <p:sp>
-        <p:nvSpPr>
           <p:cNvPr id="2" name="文本框 1"/>
           <p:cNvSpPr txBox="1"/>
           <p:nvPr/>
@@ -4654,7 +4455,7 @@
                 <a:ea typeface="微软雅黑" panose="020B0503020204020204" charset="-122"/>
                 <a:sym typeface="+mn-ea"/>
               </a:rPr>
-              <a:t>{technical_type}</a:t>
+              <a:t>{technical_name}</a:t>
             </a:r>
             <a:endParaRPr lang="en-US" sz="3600" b="1" noProof="0" dirty="0">
               <a:ln>

</xml_diff>